<commit_message>
Add speaker notes to all slides
</commit_message>
<xml_diff>
--- a/Fortune_Teller_Presentation.pptx
+++ b/Fortune_Teller_Presentation.pptx
@@ -6,11 +6,11 @@
   </p:sldMasterIdLst>
   <p:sldIdLst>
     <p:sldId id="256" r:id="rId7"/>
-    <p:sldId id="257" r:id="rId8"/>
-    <p:sldId id="258" r:id="rId9"/>
-    <p:sldId id="259" r:id="rId10"/>
-    <p:sldId id="260" r:id="rId11"/>
-    <p:sldId id="261" r:id="rId12"/>
+    <p:sldId id="257" r:id="rId9"/>
+    <p:sldId id="258" r:id="rId10"/>
+    <p:sldId id="259" r:id="rId11"/>
+    <p:sldId id="260" r:id="rId12"/>
+    <p:sldId id="261" r:id="rId13"/>
   </p:sldIdLst>
   <p:sldSz cx="12188952" cy="6858000" type="screen4x3"/>
   <p:notesSz cx="6858000" cy="9144000"/>
@@ -110,6 +110,938 @@
     </a:lvl9pPr>
   </p:defaultTextStyle>
 </p:presentation>
+</file>
+
+<file path=ppt/notesMasters/notesMaster1.xml><?xml version="1.0" encoding="utf-8"?>
+<p:notesMaster xmlns:a="http://schemas.openxmlformats.org/drawingml/2006/main" xmlns:p="http://schemas.openxmlformats.org/presentationml/2006/main" xmlns:r="http://schemas.openxmlformats.org/officeDocument/2006/relationships">
+  <p:cSld>
+    <p:bg>
+      <p:bgRef idx="1001">
+        <a:schemeClr val="bg1"/>
+      </p:bgRef>
+    </p:bg>
+    <p:spTree>
+      <p:nvGrpSpPr>
+        <p:cNvPr id="1" name=""/>
+        <p:cNvGrpSpPr/>
+        <p:nvPr/>
+      </p:nvGrpSpPr>
+      <p:grpSpPr>
+        <a:xfrm>
+          <a:off x="0" y="0"/>
+          <a:ext cx="0" cy="0"/>
+          <a:chOff x="0" y="0"/>
+          <a:chExt cx="0" cy="0"/>
+        </a:xfrm>
+      </p:grpSpPr>
+      <p:sp>
+        <p:nvSpPr>
+          <p:cNvPr id="2" name="Header Placeholder 1"/>
+          <p:cNvSpPr>
+            <a:spLocks noGrp="1"/>
+          </p:cNvSpPr>
+          <p:nvPr>
+            <p:ph type="hdr" sz="quarter"/>
+          </p:nvPr>
+        </p:nvSpPr>
+        <p:spPr>
+          <a:xfrm>
+            <a:off x="0" y="0"/>
+            <a:ext cx="2971800" cy="457200"/>
+          </a:xfrm>
+          <a:prstGeom prst="rect">
+            <a:avLst/>
+          </a:prstGeom>
+        </p:spPr>
+        <p:txBody>
+          <a:bodyPr vert="horz" lIns="91440" tIns="45720" rIns="91440" bIns="45720" rtlCol="0"/>
+          <a:lstStyle>
+            <a:lvl1pPr algn="l">
+              <a:defRPr sz="1200"/>
+            </a:lvl1pPr>
+          </a:lstStyle>
+          <a:p>
+            <a:endParaRPr lang="en-US"/>
+          </a:p>
+        </p:txBody>
+      </p:sp>
+      <p:sp>
+        <p:nvSpPr>
+          <p:cNvPr id="3" name="Date Placeholder 2"/>
+          <p:cNvSpPr>
+            <a:spLocks noGrp="1"/>
+          </p:cNvSpPr>
+          <p:nvPr>
+            <p:ph type="dt" idx="1"/>
+          </p:nvPr>
+        </p:nvSpPr>
+        <p:spPr>
+          <a:xfrm>
+            <a:off x="3884613" y="0"/>
+            <a:ext cx="2971800" cy="457200"/>
+          </a:xfrm>
+          <a:prstGeom prst="rect">
+            <a:avLst/>
+          </a:prstGeom>
+        </p:spPr>
+        <p:txBody>
+          <a:bodyPr vert="horz" lIns="91440" tIns="45720" rIns="91440" bIns="45720" rtlCol="0"/>
+          <a:lstStyle>
+            <a:lvl1pPr algn="r">
+              <a:defRPr sz="1200"/>
+            </a:lvl1pPr>
+          </a:lstStyle>
+          <a:p>
+            <a:fld id="{0F89C1C7-3DCD-1040-A9CF-14679D8B5DDD}" type="datetimeFigureOut">
+              <a:rPr lang="en-US" smtClean="0"/>
+              <a:t>10/17/16</a:t>
+            </a:fld>
+            <a:endParaRPr lang="en-US"/>
+          </a:p>
+        </p:txBody>
+      </p:sp>
+      <p:sp>
+        <p:nvSpPr>
+          <p:cNvPr id="4" name="Slide Image Placeholder 3"/>
+          <p:cNvSpPr>
+            <a:spLocks noGrp="1" noRot="1" noChangeAspect="1"/>
+          </p:cNvSpPr>
+          <p:nvPr>
+            <p:ph type="sldImg" idx="2"/>
+          </p:nvPr>
+        </p:nvSpPr>
+        <p:spPr>
+          <a:xfrm>
+            <a:off x="1143000" y="685800"/>
+            <a:ext cx="4572000" cy="3429000"/>
+          </a:xfrm>
+          <a:prstGeom prst="rect">
+            <a:avLst/>
+          </a:prstGeom>
+          <a:noFill/>
+          <a:ln w="12700">
+            <a:solidFill>
+              <a:prstClr val="black"/>
+            </a:solidFill>
+          </a:ln>
+        </p:spPr>
+        <p:txBody>
+          <a:bodyPr vert="horz" lIns="91440" tIns="45720" rIns="91440" bIns="45720" rtlCol="0" anchor="ctr"/>
+          <a:lstStyle/>
+          <a:p>
+            <a:endParaRPr lang="en-US"/>
+          </a:p>
+        </p:txBody>
+      </p:sp>
+      <p:sp>
+        <p:nvSpPr>
+          <p:cNvPr id="5" name="Notes Placeholder 4"/>
+          <p:cNvSpPr>
+            <a:spLocks noGrp="1"/>
+          </p:cNvSpPr>
+          <p:nvPr>
+            <p:ph type="body" sz="quarter" idx="3"/>
+          </p:nvPr>
+        </p:nvSpPr>
+        <p:spPr>
+          <a:xfrm>
+            <a:off x="685800" y="4343400"/>
+            <a:ext cx="5486400" cy="4114800"/>
+          </a:xfrm>
+          <a:prstGeom prst="rect">
+            <a:avLst/>
+          </a:prstGeom>
+        </p:spPr>
+        <p:txBody>
+          <a:bodyPr vert="horz" lIns="91440" tIns="45720" rIns="91440" bIns="45720" rtlCol="0"/>
+          <a:lstStyle/>
+          <a:p>
+            <a:pPr lvl="0"/>
+            <a:r>
+              <a:rPr lang="en-US" smtClean="0"/>
+              <a:t>Click to edit Master text styles</a:t>
+            </a:r>
+          </a:p>
+          <a:p>
+            <a:pPr lvl="1"/>
+            <a:r>
+              <a:rPr lang="en-US" smtClean="0"/>
+              <a:t>Second level</a:t>
+            </a:r>
+          </a:p>
+          <a:p>
+            <a:pPr lvl="2"/>
+            <a:r>
+              <a:rPr lang="en-US" smtClean="0"/>
+              <a:t>Third level</a:t>
+            </a:r>
+          </a:p>
+          <a:p>
+            <a:pPr lvl="3"/>
+            <a:r>
+              <a:rPr lang="en-US" smtClean="0"/>
+              <a:t>Fourth level</a:t>
+            </a:r>
+          </a:p>
+          <a:p>
+            <a:pPr lvl="4"/>
+            <a:r>
+              <a:rPr lang="en-US" smtClean="0"/>
+              <a:t>Fifth level</a:t>
+            </a:r>
+            <a:endParaRPr lang="en-US"/>
+          </a:p>
+        </p:txBody>
+      </p:sp>
+      <p:sp>
+        <p:nvSpPr>
+          <p:cNvPr id="6" name="Footer Placeholder 5"/>
+          <p:cNvSpPr>
+            <a:spLocks noGrp="1"/>
+          </p:cNvSpPr>
+          <p:nvPr>
+            <p:ph type="ftr" sz="quarter" idx="4"/>
+          </p:nvPr>
+        </p:nvSpPr>
+        <p:spPr>
+          <a:xfrm>
+            <a:off x="0" y="8685213"/>
+            <a:ext cx="2971800" cy="457200"/>
+          </a:xfrm>
+          <a:prstGeom prst="rect">
+            <a:avLst/>
+          </a:prstGeom>
+        </p:spPr>
+        <p:txBody>
+          <a:bodyPr vert="horz" lIns="91440" tIns="45720" rIns="91440" bIns="45720" rtlCol="0" anchor="b"/>
+          <a:lstStyle>
+            <a:lvl1pPr algn="l">
+              <a:defRPr sz="1200"/>
+            </a:lvl1pPr>
+          </a:lstStyle>
+          <a:p>
+            <a:endParaRPr lang="en-US"/>
+          </a:p>
+        </p:txBody>
+      </p:sp>
+      <p:sp>
+        <p:nvSpPr>
+          <p:cNvPr id="7" name="Slide Number Placeholder 6"/>
+          <p:cNvSpPr>
+            <a:spLocks noGrp="1"/>
+          </p:cNvSpPr>
+          <p:nvPr>
+            <p:ph type="sldNum" sz="quarter" idx="5"/>
+          </p:nvPr>
+        </p:nvSpPr>
+        <p:spPr>
+          <a:xfrm>
+            <a:off x="3884613" y="8685213"/>
+            <a:ext cx="2971800" cy="457200"/>
+          </a:xfrm>
+          <a:prstGeom prst="rect">
+            <a:avLst/>
+          </a:prstGeom>
+        </p:spPr>
+        <p:txBody>
+          <a:bodyPr vert="horz" lIns="91440" tIns="45720" rIns="91440" bIns="45720" rtlCol="0" anchor="b"/>
+          <a:lstStyle>
+            <a:lvl1pPr algn="r">
+              <a:defRPr sz="1200"/>
+            </a:lvl1pPr>
+          </a:lstStyle>
+          <a:p>
+            <a:fld id="{BB5E49A5-4136-284D-997B-48E1D791AD67}" type="slidenum">
+              <a:rPr lang="en-US" smtClean="0"/>
+              <a:t>‹#›</a:t>
+            </a:fld>
+            <a:endParaRPr lang="en-US"/>
+          </a:p>
+        </p:txBody>
+      </p:sp>
+    </p:spTree>
+    <p:extLst>
+      <p:ext uri="{BB962C8B-B14F-4D97-AF65-F5344CB8AC3E}">
+        <p14:creationId xmlns:p14="http://schemas.microsoft.com/office/powerpoint/2010/main" val="2623252185"/>
+      </p:ext>
+    </p:extLst>
+  </p:cSld>
+  <p:clrMap bg1="lt1" tx1="dk1" bg2="lt2" tx2="dk2" accent1="accent1" accent2="accent2" accent3="accent3" accent4="accent4" accent5="accent5" accent6="accent6" hlink="hlink" folHlink="folHlink"/>
+  <p:notesStyle>
+    <a:lvl1pPr marL="0" algn="l" defTabSz="457200" rtl="0" eaLnBrk="1" latinLnBrk="0" hangingPunct="1">
+      <a:defRPr sz="1200" kern="1200">
+        <a:solidFill>
+          <a:schemeClr val="tx1"/>
+        </a:solidFill>
+        <a:latin typeface="+mn-lt"/>
+        <a:ea typeface="+mn-ea"/>
+        <a:cs typeface="+mn-cs"/>
+      </a:defRPr>
+    </a:lvl1pPr>
+    <a:lvl2pPr marL="457200" algn="l" defTabSz="457200" rtl="0" eaLnBrk="1" latinLnBrk="0" hangingPunct="1">
+      <a:defRPr sz="1200" kern="1200">
+        <a:solidFill>
+          <a:schemeClr val="tx1"/>
+        </a:solidFill>
+        <a:latin typeface="+mn-lt"/>
+        <a:ea typeface="+mn-ea"/>
+        <a:cs typeface="+mn-cs"/>
+      </a:defRPr>
+    </a:lvl2pPr>
+    <a:lvl3pPr marL="914400" algn="l" defTabSz="457200" rtl="0" eaLnBrk="1" latinLnBrk="0" hangingPunct="1">
+      <a:defRPr sz="1200" kern="1200">
+        <a:solidFill>
+          <a:schemeClr val="tx1"/>
+        </a:solidFill>
+        <a:latin typeface="+mn-lt"/>
+        <a:ea typeface="+mn-ea"/>
+        <a:cs typeface="+mn-cs"/>
+      </a:defRPr>
+    </a:lvl3pPr>
+    <a:lvl4pPr marL="1371600" algn="l" defTabSz="457200" rtl="0" eaLnBrk="1" latinLnBrk="0" hangingPunct="1">
+      <a:defRPr sz="1200" kern="1200">
+        <a:solidFill>
+          <a:schemeClr val="tx1"/>
+        </a:solidFill>
+        <a:latin typeface="+mn-lt"/>
+        <a:ea typeface="+mn-ea"/>
+        <a:cs typeface="+mn-cs"/>
+      </a:defRPr>
+    </a:lvl4pPr>
+    <a:lvl5pPr marL="1828800" algn="l" defTabSz="457200" rtl="0" eaLnBrk="1" latinLnBrk="0" hangingPunct="1">
+      <a:defRPr sz="1200" kern="1200">
+        <a:solidFill>
+          <a:schemeClr val="tx1"/>
+        </a:solidFill>
+        <a:latin typeface="+mn-lt"/>
+        <a:ea typeface="+mn-ea"/>
+        <a:cs typeface="+mn-cs"/>
+      </a:defRPr>
+    </a:lvl5pPr>
+    <a:lvl6pPr marL="2286000" algn="l" defTabSz="457200" rtl="0" eaLnBrk="1" latinLnBrk="0" hangingPunct="1">
+      <a:defRPr sz="1200" kern="1200">
+        <a:solidFill>
+          <a:schemeClr val="tx1"/>
+        </a:solidFill>
+        <a:latin typeface="+mn-lt"/>
+        <a:ea typeface="+mn-ea"/>
+        <a:cs typeface="+mn-cs"/>
+      </a:defRPr>
+    </a:lvl6pPr>
+    <a:lvl7pPr marL="2743200" algn="l" defTabSz="457200" rtl="0" eaLnBrk="1" latinLnBrk="0" hangingPunct="1">
+      <a:defRPr sz="1200" kern="1200">
+        <a:solidFill>
+          <a:schemeClr val="tx1"/>
+        </a:solidFill>
+        <a:latin typeface="+mn-lt"/>
+        <a:ea typeface="+mn-ea"/>
+        <a:cs typeface="+mn-cs"/>
+      </a:defRPr>
+    </a:lvl7pPr>
+    <a:lvl8pPr marL="3200400" algn="l" defTabSz="457200" rtl="0" eaLnBrk="1" latinLnBrk="0" hangingPunct="1">
+      <a:defRPr sz="1200" kern="1200">
+        <a:solidFill>
+          <a:schemeClr val="tx1"/>
+        </a:solidFill>
+        <a:latin typeface="+mn-lt"/>
+        <a:ea typeface="+mn-ea"/>
+        <a:cs typeface="+mn-cs"/>
+      </a:defRPr>
+    </a:lvl8pPr>
+    <a:lvl9pPr marL="3657600" algn="l" defTabSz="457200" rtl="0" eaLnBrk="1" latinLnBrk="0" hangingPunct="1">
+      <a:defRPr sz="1200" kern="1200">
+        <a:solidFill>
+          <a:schemeClr val="tx1"/>
+        </a:solidFill>
+        <a:latin typeface="+mn-lt"/>
+        <a:ea typeface="+mn-ea"/>
+        <a:cs typeface="+mn-cs"/>
+      </a:defRPr>
+    </a:lvl9pPr>
+  </p:notesStyle>
+</p:notesMaster>
+</file>
+
+<file path=ppt/notesSlides/notesSlide1.xml><?xml version="1.0" encoding="utf-8"?>
+<p:notes xmlns:a="http://schemas.openxmlformats.org/drawingml/2006/main" xmlns:p="http://schemas.openxmlformats.org/presentationml/2006/main" xmlns:r="http://schemas.openxmlformats.org/officeDocument/2006/relationships">
+  <p:cSld>
+    <p:spTree>
+      <p:nvGrpSpPr>
+        <p:cNvPr id="1" name=""/>
+        <p:cNvGrpSpPr/>
+        <p:nvPr/>
+      </p:nvGrpSpPr>
+      <p:grpSpPr>
+        <a:xfrm>
+          <a:off x="0" y="0"/>
+          <a:ext cx="0" cy="0"/>
+          <a:chOff x="0" y="0"/>
+          <a:chExt cx="0" cy="0"/>
+        </a:xfrm>
+      </p:grpSpPr>
+      <p:sp>
+        <p:nvSpPr>
+          <p:cNvPr id="2" name="Slide Image Placeholder 1"/>
+          <p:cNvSpPr>
+            <a:spLocks noGrp="1"/>
+          </p:cNvSpPr>
+          <p:nvPr>
+            <p:ph type="sldImg" idx="2"/>
+          </p:nvPr>
+        </p:nvSpPr>
+        <p:spPr/>
+      </p:sp>
+      <p:sp>
+        <p:nvSpPr>
+          <p:cNvPr id="3" name="Notes Placeholder 2"/>
+          <p:cNvSpPr>
+            <a:spLocks noGrp="1"/>
+          </p:cNvSpPr>
+          <p:nvPr>
+            <p:ph type="body" idx="3" sz="quarter"/>
+          </p:nvPr>
+        </p:nvSpPr>
+        <p:spPr/>
+        <p:txBody>
+          <a:bodyPr/>
+          <a:lstStyle/>
+          <a:p>
+            <a:r>
+              <a:t>Hello everyone. My name is Wannakorn Sangthongngam.</a:t>
+            </a:r>
+          </a:p>
+          <a:p/>
+          <a:p>
+            <a:r>
+              <a:t>Today I am presenting Fortune Teller — an AI-powered system that can recognize tarot cards from photos and generate fortune readings.</a:t>
+            </a:r>
+          </a:p>
+          <a:p/>
+          <a:p>
+            <a:r>
+              <a:t>The project uses EfficientNet-B0, a state-of-the-art image classification model built with PyTorch, trained using transfer learning from ImageNet.</a:t>
+            </a:r>
+          </a:p>
+          <a:p/>
+          <a:p>
+            <a:r>
+              <a:t>Let me walk you through the project from motivation to roadmap.</a:t>
+            </a:r>
+          </a:p>
+        </p:txBody>
+      </p:sp>
+      <p:sp>
+        <p:nvSpPr>
+          <p:cNvPr id="4" name="Slide Number Placeholder 3"/>
+          <p:cNvSpPr>
+            <a:spLocks noGrp="1"/>
+          </p:cNvSpPr>
+          <p:nvPr>
+            <p:ph type="sldNum" idx="5" sz="quarter"/>
+          </p:nvPr>
+        </p:nvSpPr>
+        <p:spPr/>
+      </p:sp>
+    </p:spTree>
+  </p:cSld>
+  <p:clrMapOvr>
+    <a:masterClrMapping/>
+  </p:clrMapOvr>
+</p:notes>
+</file>
+
+<file path=ppt/notesSlides/notesSlide2.xml><?xml version="1.0" encoding="utf-8"?>
+<p:notes xmlns:a="http://schemas.openxmlformats.org/drawingml/2006/main" xmlns:p="http://schemas.openxmlformats.org/presentationml/2006/main" xmlns:r="http://schemas.openxmlformats.org/officeDocument/2006/relationships">
+  <p:cSld>
+    <p:spTree>
+      <p:nvGrpSpPr>
+        <p:cNvPr id="1" name=""/>
+        <p:cNvGrpSpPr/>
+        <p:nvPr/>
+      </p:nvGrpSpPr>
+      <p:grpSpPr>
+        <a:xfrm>
+          <a:off x="0" y="0"/>
+          <a:ext cx="0" cy="0"/>
+          <a:chOff x="0" y="0"/>
+          <a:chExt cx="0" cy="0"/>
+        </a:xfrm>
+      </p:grpSpPr>
+      <p:sp>
+        <p:nvSpPr>
+          <p:cNvPr id="2" name="Slide Image Placeholder 1"/>
+          <p:cNvSpPr>
+            <a:spLocks noGrp="1"/>
+          </p:cNvSpPr>
+          <p:nvPr>
+            <p:ph type="sldImg" idx="2"/>
+          </p:nvPr>
+        </p:nvSpPr>
+        <p:spPr/>
+      </p:sp>
+      <p:sp>
+        <p:nvSpPr>
+          <p:cNvPr id="3" name="Notes Placeholder 2"/>
+          <p:cNvSpPr>
+            <a:spLocks noGrp="1"/>
+          </p:cNvSpPr>
+          <p:nvPr>
+            <p:ph type="body" idx="3" sz="quarter"/>
+          </p:nvPr>
+        </p:nvSpPr>
+        <p:spPr/>
+        <p:txBody>
+          <a:bodyPr/>
+          <a:lstStyle/>
+          <a:p>
+            <a:r>
+              <a:t>Fortune Teller is a system that combines computer vision and tarot card knowledge.</a:t>
+            </a:r>
+          </a:p>
+          <a:p/>
+          <a:p>
+            <a:r>
+              <a:t>The idea is simple — the user takes a photo of a tarot card, the AI model identifies which card it is, and then the system displays the fortune meaning associated with that card.</a:t>
+            </a:r>
+          </a:p>
+          <a:p/>
+          <a:p>
+            <a:r>
+              <a:t>There are 78 cards in a standard tarot deck, each with its own meaning and symbolism.</a:t>
+            </a:r>
+          </a:p>
+          <a:p/>
+          <a:p>
+            <a:r>
+              <a:t>On the technology side, we use PyTorch as the deep learning framework, EfficientNet-B0 as the model backbone, and Google Colab for training on a free GPU.</a:t>
+            </a:r>
+          </a:p>
+          <a:p/>
+          <a:p>
+            <a:r>
+              <a:t>The bottom of this slide shows the full pipeline: Photo → AI Model → Card Identification → Fortune Reading.</a:t>
+            </a:r>
+          </a:p>
+        </p:txBody>
+      </p:sp>
+      <p:sp>
+        <p:nvSpPr>
+          <p:cNvPr id="4" name="Slide Number Placeholder 3"/>
+          <p:cNvSpPr>
+            <a:spLocks noGrp="1"/>
+          </p:cNvSpPr>
+          <p:nvPr>
+            <p:ph type="sldNum" idx="5" sz="quarter"/>
+          </p:nvPr>
+        </p:nvSpPr>
+        <p:spPr/>
+      </p:sp>
+    </p:spTree>
+  </p:cSld>
+  <p:clrMapOvr>
+    <a:masterClrMapping/>
+  </p:clrMapOvr>
+</p:notes>
+</file>
+
+<file path=ppt/notesSlides/notesSlide3.xml><?xml version="1.0" encoding="utf-8"?>
+<p:notes xmlns:a="http://schemas.openxmlformats.org/drawingml/2006/main" xmlns:p="http://schemas.openxmlformats.org/presentationml/2006/main" xmlns:r="http://schemas.openxmlformats.org/officeDocument/2006/relationships">
+  <p:cSld>
+    <p:spTree>
+      <p:nvGrpSpPr>
+        <p:cNvPr id="1" name=""/>
+        <p:cNvGrpSpPr/>
+        <p:nvPr/>
+      </p:nvGrpSpPr>
+      <p:grpSpPr>
+        <a:xfrm>
+          <a:off x="0" y="0"/>
+          <a:ext cx="0" cy="0"/>
+          <a:chOff x="0" y="0"/>
+          <a:chExt cx="0" cy="0"/>
+        </a:xfrm>
+      </p:grpSpPr>
+      <p:sp>
+        <p:nvSpPr>
+          <p:cNvPr id="2" name="Slide Image Placeholder 1"/>
+          <p:cNvSpPr>
+            <a:spLocks noGrp="1"/>
+          </p:cNvSpPr>
+          <p:nvPr>
+            <p:ph type="sldImg" idx="2"/>
+          </p:nvPr>
+        </p:nvSpPr>
+        <p:spPr/>
+      </p:sp>
+      <p:sp>
+        <p:nvSpPr>
+          <p:cNvPr id="3" name="Notes Placeholder 2"/>
+          <p:cNvSpPr>
+            <a:spLocks noGrp="1"/>
+          </p:cNvSpPr>
+          <p:nvPr>
+            <p:ph type="body" idx="3" sz="quarter"/>
+          </p:nvPr>
+        </p:nvSpPr>
+        <p:spPr/>
+        <p:txBody>
+          <a:bodyPr/>
+          <a:lstStyle/>
+          <a:p>
+            <a:r>
+              <a:t>The main challenge of this project is that tarot cards are visually complex — each of the 78 cards has unique symbols, figures, and color patterns that the model must learn to distinguish.</a:t>
+            </a:r>
+          </a:p>
+          <a:p/>
+          <a:p>
+            <a:r>
+              <a:t>The biggest constraint is our small dataset. We only have around 30 photos per card, which is far too little to train a neural network from scratch.</a:t>
+            </a:r>
+          </a:p>
+          <a:p/>
+          <a:p>
+            <a:r>
+              <a:t>Our solution is transfer learning. Instead of starting from random weights, we use EfficientNet-B0 which was already trained on 1.2 million images from ImageNet. The model already knows how to detect edges, shapes, textures, and patterns.</a:t>
+            </a:r>
+          </a:p>
+          <a:p/>
+          <a:p>
+            <a:r>
+              <a:t>We then apply data augmentation — randomly flipping, rotating, and adjusting colors — to artificially create more variety from our small set of photos.</a:t>
+            </a:r>
+          </a:p>
+          <a:p/>
+          <a:p>
+            <a:r>
+              <a:t>Finally, we use a 2-phase training strategy: first train only the classification head while the backbone is frozen, then unfreeze everything for fine-tuning.</a:t>
+            </a:r>
+          </a:p>
+        </p:txBody>
+      </p:sp>
+      <p:sp>
+        <p:nvSpPr>
+          <p:cNvPr id="4" name="Slide Number Placeholder 3"/>
+          <p:cNvSpPr>
+            <a:spLocks noGrp="1"/>
+          </p:cNvSpPr>
+          <p:nvPr>
+            <p:ph type="sldNum" idx="5" sz="quarter"/>
+          </p:nvPr>
+        </p:nvSpPr>
+        <p:spPr/>
+      </p:sp>
+    </p:spTree>
+  </p:cSld>
+  <p:clrMapOvr>
+    <a:masterClrMapping/>
+  </p:clrMapOvr>
+</p:notes>
+</file>
+
+<file path=ppt/notesSlides/notesSlide4.xml><?xml version="1.0" encoding="utf-8"?>
+<p:notes xmlns:a="http://schemas.openxmlformats.org/drawingml/2006/main" xmlns:p="http://schemas.openxmlformats.org/presentationml/2006/main" xmlns:r="http://schemas.openxmlformats.org/officeDocument/2006/relationships">
+  <p:cSld>
+    <p:spTree>
+      <p:nvGrpSpPr>
+        <p:cNvPr id="1" name=""/>
+        <p:cNvGrpSpPr/>
+        <p:nvPr/>
+      </p:nvGrpSpPr>
+      <p:grpSpPr>
+        <a:xfrm>
+          <a:off x="0" y="0"/>
+          <a:ext cx="0" cy="0"/>
+          <a:chOff x="0" y="0"/>
+          <a:chExt cx="0" cy="0"/>
+        </a:xfrm>
+      </p:grpSpPr>
+      <p:sp>
+        <p:nvSpPr>
+          <p:cNvPr id="2" name="Slide Image Placeholder 1"/>
+          <p:cNvSpPr>
+            <a:spLocks noGrp="1"/>
+          </p:cNvSpPr>
+          <p:nvPr>
+            <p:ph type="sldImg" idx="2"/>
+          </p:nvPr>
+        </p:nvSpPr>
+        <p:spPr/>
+      </p:sp>
+      <p:sp>
+        <p:nvSpPr>
+          <p:cNvPr id="3" name="Notes Placeholder 2"/>
+          <p:cNvSpPr>
+            <a:spLocks noGrp="1"/>
+          </p:cNvSpPr>
+          <p:nvPr>
+            <p:ph type="body" idx="3" sz="quarter"/>
+          </p:nvPr>
+        </p:nvSpPr>
+        <p:spPr/>
+        <p:txBody>
+          <a:bodyPr/>
+          <a:lstStyle/>
+          <a:p>
+            <a:r>
+              <a:t>This slide shows the full architecture of our model.</a:t>
+            </a:r>
+          </a:p>
+          <a:p/>
+          <a:p>
+            <a:r>
+              <a:t>Starting from the left — the input is an image resized to 224 by 224 pixels with 3 color channels.</a:t>
+            </a:r>
+          </a:p>
+          <a:p/>
+          <a:p>
+            <a:r>
+              <a:t>It then passes through the EfficientNet-B0 backbone, which was pretrained on ImageNet. This backbone acts as a powerful feature extractor — it outputs a 1280-dimensional feature vector summarizing what it sees in the image.</a:t>
+            </a:r>
+          </a:p>
+          <a:p/>
+          <a:p>
+            <a:r>
+              <a:t>We then add our custom classification head on top: a Dropout layer to prevent overfitting, a Linear layer reducing 1280 to 512 dimensions, a ReLU activation, another Dropout, and finally a Linear layer outputting 78 scores — one for each tarot card.</a:t>
+            </a:r>
+          </a:p>
+          <a:p/>
+          <a:p>
+            <a:r>
+              <a:t>The card with the highest score is the prediction.</a:t>
+            </a:r>
+          </a:p>
+          <a:p/>
+          <a:p>
+            <a:r>
+              <a:t>Why EfficientNet-B0? It scales depth, width, and resolution together, giving the best accuracy per number of parameters. It has only 5.3 million parameters, making it fast enough to run on a laptop CPU.</a:t>
+            </a:r>
+          </a:p>
+        </p:txBody>
+      </p:sp>
+      <p:sp>
+        <p:nvSpPr>
+          <p:cNvPr id="4" name="Slide Number Placeholder 3"/>
+          <p:cNvSpPr>
+            <a:spLocks noGrp="1"/>
+          </p:cNvSpPr>
+          <p:nvPr>
+            <p:ph type="sldNum" idx="5" sz="quarter"/>
+          </p:nvPr>
+        </p:nvSpPr>
+        <p:spPr/>
+      </p:sp>
+    </p:spTree>
+  </p:cSld>
+  <p:clrMapOvr>
+    <a:masterClrMapping/>
+  </p:clrMapOvr>
+</p:notes>
+</file>
+
+<file path=ppt/notesSlides/notesSlide5.xml><?xml version="1.0" encoding="utf-8"?>
+<p:notes xmlns:a="http://schemas.openxmlformats.org/drawingml/2006/main" xmlns:p="http://schemas.openxmlformats.org/presentationml/2006/main" xmlns:r="http://schemas.openxmlformats.org/officeDocument/2006/relationships">
+  <p:cSld>
+    <p:spTree>
+      <p:nvGrpSpPr>
+        <p:cNvPr id="1" name=""/>
+        <p:cNvGrpSpPr/>
+        <p:nvPr/>
+      </p:nvGrpSpPr>
+      <p:grpSpPr>
+        <a:xfrm>
+          <a:off x="0" y="0"/>
+          <a:ext cx="0" cy="0"/>
+          <a:chOff x="0" y="0"/>
+          <a:chExt cx="0" cy="0"/>
+        </a:xfrm>
+      </p:grpSpPr>
+      <p:sp>
+        <p:nvSpPr>
+          <p:cNvPr id="2" name="Slide Image Placeholder 1"/>
+          <p:cNvSpPr>
+            <a:spLocks noGrp="1"/>
+          </p:cNvSpPr>
+          <p:nvPr>
+            <p:ph type="sldImg" idx="2"/>
+          </p:nvPr>
+        </p:nvSpPr>
+        <p:spPr/>
+      </p:sp>
+      <p:sp>
+        <p:nvSpPr>
+          <p:cNvPr id="3" name="Notes Placeholder 2"/>
+          <p:cNvSpPr>
+            <a:spLocks noGrp="1"/>
+          </p:cNvSpPr>
+          <p:nvPr>
+            <p:ph type="body" idx="3" sz="quarter"/>
+          </p:nvPr>
+        </p:nvSpPr>
+        <p:spPr/>
+        <p:txBody>
+          <a:bodyPr/>
+          <a:lstStyle/>
+          <a:p>
+            <a:r>
+              <a:t>Our training pipeline has three stages.</a:t>
+            </a:r>
+          </a:p>
+          <a:p/>
+          <a:p>
+            <a:r>
+              <a:t>First, data preparation. We collect around 30 photos per card for all 78 cards. The photos are taken on an iPhone in HEIC format and organized into folders — one folder per card. The dataset is then split into 75% training, 15% validation, and 10% test.</a:t>
+            </a:r>
+          </a:p>
+          <a:p/>
+          <a:p>
+            <a:r>
+              <a:t>Second, Phase 1 training. We freeze the EfficientNet backbone so its pretrained ImageNet weights are not changed. Only our custom classification head is trained. We use the Adam optimizer with a learning rate of 1e-3 for 10 epochs. This phase converges quickly because the backbone already extracts good features.</a:t>
+            </a:r>
+          </a:p>
+          <a:p/>
+          <a:p>
+            <a:r>
+              <a:t>Third, Phase 2 fine-tuning. We unfreeze all layers and train the entire network at a lower learning rate of 1e-4 for 20 more epochs. This allows the backbone to slightly adjust to tarot card features. The best model based on validation accuracy is saved automatically.</a:t>
+            </a:r>
+          </a:p>
+          <a:p/>
+          <a:p>
+            <a:r>
+              <a:t>The augmentation pipeline shown at the bottom helps the model generalize by seeing different versions of each photo during training.</a:t>
+            </a:r>
+          </a:p>
+        </p:txBody>
+      </p:sp>
+      <p:sp>
+        <p:nvSpPr>
+          <p:cNvPr id="4" name="Slide Number Placeholder 3"/>
+          <p:cNvSpPr>
+            <a:spLocks noGrp="1"/>
+          </p:cNvSpPr>
+          <p:nvPr>
+            <p:ph type="sldNum" idx="5" sz="quarter"/>
+          </p:nvPr>
+        </p:nvSpPr>
+        <p:spPr/>
+      </p:sp>
+    </p:spTree>
+  </p:cSld>
+  <p:clrMapOvr>
+    <a:masterClrMapping/>
+  </p:clrMapOvr>
+</p:notes>
+</file>
+
+<file path=ppt/notesSlides/notesSlide6.xml><?xml version="1.0" encoding="utf-8"?>
+<p:notes xmlns:a="http://schemas.openxmlformats.org/drawingml/2006/main" xmlns:p="http://schemas.openxmlformats.org/presentationml/2006/main" xmlns:r="http://schemas.openxmlformats.org/officeDocument/2006/relationships">
+  <p:cSld>
+    <p:spTree>
+      <p:nvGrpSpPr>
+        <p:cNvPr id="1" name=""/>
+        <p:cNvGrpSpPr/>
+        <p:nvPr/>
+      </p:nvGrpSpPr>
+      <p:grpSpPr>
+        <a:xfrm>
+          <a:off x="0" y="0"/>
+          <a:ext cx="0" cy="0"/>
+          <a:chOff x="0" y="0"/>
+          <a:chExt cx="0" cy="0"/>
+        </a:xfrm>
+      </p:grpSpPr>
+      <p:sp>
+        <p:nvSpPr>
+          <p:cNvPr id="2" name="Slide Image Placeholder 1"/>
+          <p:cNvSpPr>
+            <a:spLocks noGrp="1"/>
+          </p:cNvSpPr>
+          <p:nvPr>
+            <p:ph type="sldImg" idx="2"/>
+          </p:nvPr>
+        </p:nvSpPr>
+        <p:spPr/>
+      </p:sp>
+      <p:sp>
+        <p:nvSpPr>
+          <p:cNvPr id="3" name="Notes Placeholder 2"/>
+          <p:cNvSpPr>
+            <a:spLocks noGrp="1"/>
+          </p:cNvSpPr>
+          <p:nvPr>
+            <p:ph type="body" idx="3" sz="quarter"/>
+          </p:nvPr>
+        </p:nvSpPr>
+        <p:spPr/>
+        <p:txBody>
+          <a:bodyPr/>
+          <a:lstStyle/>
+          <a:p>
+            <a:r>
+              <a:t>This roadmap outlines the five phases of the project.</a:t>
+            </a:r>
+          </a:p>
+          <a:p/>
+          <a:p>
+            <a:r>
+              <a:t>Phase 1 is currently in progress — we are photographing all 78 tarot cards, around 30 shots each, using an iPhone.</a:t>
+            </a:r>
+          </a:p>
+          <a:p/>
+          <a:p>
+            <a:r>
+              <a:t>Phase 2 will be model training on Google Colab using a free T4 GPU. We expect this to take around 30 to 60 minutes once the photos are ready.</a:t>
+            </a:r>
+          </a:p>
+          <a:p/>
+          <a:p>
+            <a:r>
+              <a:t>Phase 3 is the prediction module — given a new photo, the model returns the top 3 most likely cards with confidence scores.</a:t>
+            </a:r>
+          </a:p>
+          <a:p/>
+          <a:p>
+            <a:r>
+              <a:t>Phase 4 adds the fortune telling logic — mapping the predicted card to its traditional meaning and generating a reading for the user.</a:t>
+            </a:r>
+          </a:p>
+          <a:p/>
+          <a:p>
+            <a:r>
+              <a:t>Phase 5 is the final application — a user interface where someone can take a photo and receive their fortune in real time.</a:t>
+            </a:r>
+          </a:p>
+          <a:p/>
+          <a:p>
+            <a:r>
+              <a:t>Each phase builds directly on the previous one. The foundation we are building now — a clean dataset and a well-trained model — is what makes everything else possible.</a:t>
+            </a:r>
+          </a:p>
+          <a:p/>
+          <a:p>
+            <a:r>
+              <a:t>Thank you for listening. I am happy to answer any questions.</a:t>
+            </a:r>
+          </a:p>
+        </p:txBody>
+      </p:sp>
+      <p:sp>
+        <p:nvSpPr>
+          <p:cNvPr id="4" name="Slide Number Placeholder 3"/>
+          <p:cNvSpPr>
+            <a:spLocks noGrp="1"/>
+          </p:cNvSpPr>
+          <p:nvPr>
+            <p:ph type="sldNum" idx="5" sz="quarter"/>
+          </p:nvPr>
+        </p:nvSpPr>
+        <p:spPr/>
+      </p:sp>
+    </p:spTree>
+  </p:cSld>
+  <p:clrMapOvr>
+    <a:masterClrMapping/>
+  </p:clrMapOvr>
+</p:notes>
 </file>
 
 <file path=ppt/slideLayouts/slideLayout1.xml><?xml version="1.0" encoding="utf-8"?>
@@ -10959,4 +11891,324 @@
   </a:objectDefaults>
   <a:extraClrSchemeLst/>
 </a:theme>
+</file>
+
+<file path=ppt/theme/theme2.xml><?xml version="1.0" encoding="utf-8"?>
+<a:theme xmlns:a="http://schemas.openxmlformats.org/drawingml/2006/main" name="Office Theme">
+  <a:themeElements>
+    <a:clrScheme name="Office">
+      <a:dk1>
+        <a:sysClr val="windowText" lastClr="000000"/>
+      </a:dk1>
+      <a:lt1>
+        <a:sysClr val="window" lastClr="FFFFFF"/>
+      </a:lt1>
+      <a:dk2>
+        <a:srgbClr val="1F497D"/>
+      </a:dk2>
+      <a:lt2>
+        <a:srgbClr val="EEECE1"/>
+      </a:lt2>
+      <a:accent1>
+        <a:srgbClr val="4F81BD"/>
+      </a:accent1>
+      <a:accent2>
+        <a:srgbClr val="C0504D"/>
+      </a:accent2>
+      <a:accent3>
+        <a:srgbClr val="9BBB59"/>
+      </a:accent3>
+      <a:accent4>
+        <a:srgbClr val="8064A2"/>
+      </a:accent4>
+      <a:accent5>
+        <a:srgbClr val="4BACC6"/>
+      </a:accent5>
+      <a:accent6>
+        <a:srgbClr val="F79646"/>
+      </a:accent6>
+      <a:hlink>
+        <a:srgbClr val="0000FF"/>
+      </a:hlink>
+      <a:folHlink>
+        <a:srgbClr val="800080"/>
+      </a:folHlink>
+    </a:clrScheme>
+    <a:fontScheme name="Office">
+      <a:majorFont>
+        <a:latin typeface="Calibri"/>
+        <a:ea typeface=""/>
+        <a:cs typeface=""/>
+        <a:font script="Jpan" typeface="ＭＳ Ｐゴシック"/>
+        <a:font script="Hang" typeface="맑은 고딕"/>
+        <a:font script="Hans" typeface="宋体"/>
+        <a:font script="Hant" typeface="新細明體"/>
+        <a:font script="Arab" typeface="Times New Roman"/>
+        <a:font script="Hebr" typeface="Times New Roman"/>
+        <a:font script="Thai" typeface="Angsana New"/>
+        <a:font script="Ethi" typeface="Nyala"/>
+        <a:font script="Beng" typeface="Vrinda"/>
+        <a:font script="Gujr" typeface="Shruti"/>
+        <a:font script="Khmr" typeface="MoolBoran"/>
+        <a:font script="Knda" typeface="Tunga"/>
+        <a:font script="Guru" typeface="Raavi"/>
+        <a:font script="Cans" typeface="Euphemia"/>
+        <a:font script="Cher" typeface="Plantagenet Cherokee"/>
+        <a:font script="Yiii" typeface="Microsoft Yi Baiti"/>
+        <a:font script="Tibt" typeface="Microsoft Himalaya"/>
+        <a:font script="Thaa" typeface="MV Boli"/>
+        <a:font script="Deva" typeface="Mangal"/>
+        <a:font script="Telu" typeface="Gautami"/>
+        <a:font script="Taml" typeface="Latha"/>
+        <a:font script="Syrc" typeface="Estrangelo Edessa"/>
+        <a:font script="Orya" typeface="Kalinga"/>
+        <a:font script="Mlym" typeface="Kartika"/>
+        <a:font script="Laoo" typeface="DokChampa"/>
+        <a:font script="Sinh" typeface="Iskoola Pota"/>
+        <a:font script="Mong" typeface="Mongolian Baiti"/>
+        <a:font script="Viet" typeface="Times New Roman"/>
+        <a:font script="Uigh" typeface="Microsoft Uighur"/>
+        <a:font script="Geor" typeface="Sylfaen"/>
+      </a:majorFont>
+      <a:minorFont>
+        <a:latin typeface="Calibri"/>
+        <a:ea typeface=""/>
+        <a:cs typeface=""/>
+        <a:font script="Jpan" typeface="ＭＳ Ｐゴシック"/>
+        <a:font script="Hang" typeface="맑은 고딕"/>
+        <a:font script="Hans" typeface="宋体"/>
+        <a:font script="Hant" typeface="新細明體"/>
+        <a:font script="Arab" typeface="Arial"/>
+        <a:font script="Hebr" typeface="Arial"/>
+        <a:font script="Thai" typeface="Cordia New"/>
+        <a:font script="Ethi" typeface="Nyala"/>
+        <a:font script="Beng" typeface="Vrinda"/>
+        <a:font script="Gujr" typeface="Shruti"/>
+        <a:font script="Khmr" typeface="DaunPenh"/>
+        <a:font script="Knda" typeface="Tunga"/>
+        <a:font script="Guru" typeface="Raavi"/>
+        <a:font script="Cans" typeface="Euphemia"/>
+        <a:font script="Cher" typeface="Plantagenet Cherokee"/>
+        <a:font script="Yiii" typeface="Microsoft Yi Baiti"/>
+        <a:font script="Tibt" typeface="Microsoft Himalaya"/>
+        <a:font script="Thaa" typeface="MV Boli"/>
+        <a:font script="Deva" typeface="Mangal"/>
+        <a:font script="Telu" typeface="Gautami"/>
+        <a:font script="Taml" typeface="Latha"/>
+        <a:font script="Syrc" typeface="Estrangelo Edessa"/>
+        <a:font script="Orya" typeface="Kalinga"/>
+        <a:font script="Mlym" typeface="Kartika"/>
+        <a:font script="Laoo" typeface="DokChampa"/>
+        <a:font script="Sinh" typeface="Iskoola Pota"/>
+        <a:font script="Mong" typeface="Mongolian Baiti"/>
+        <a:font script="Viet" typeface="Arial"/>
+        <a:font script="Uigh" typeface="Microsoft Uighur"/>
+        <a:font script="Geor" typeface="Sylfaen"/>
+      </a:minorFont>
+    </a:fontScheme>
+    <a:fmtScheme name="Office">
+      <a:fillStyleLst>
+        <a:solidFill>
+          <a:schemeClr val="phClr"/>
+        </a:solidFill>
+        <a:gradFill rotWithShape="1">
+          <a:gsLst>
+            <a:gs pos="0">
+              <a:schemeClr val="phClr">
+                <a:tint val="50000"/>
+                <a:satMod val="300000"/>
+              </a:schemeClr>
+            </a:gs>
+            <a:gs pos="35000">
+              <a:schemeClr val="phClr">
+                <a:tint val="37000"/>
+                <a:satMod val="300000"/>
+              </a:schemeClr>
+            </a:gs>
+            <a:gs pos="100000">
+              <a:schemeClr val="phClr">
+                <a:tint val="15000"/>
+                <a:satMod val="350000"/>
+              </a:schemeClr>
+            </a:gs>
+          </a:gsLst>
+          <a:lin ang="16200000" scaled="1"/>
+        </a:gradFill>
+        <a:gradFill rotWithShape="1">
+          <a:gsLst>
+            <a:gs pos="0">
+              <a:schemeClr val="phClr">
+                <a:tint val="100000"/>
+                <a:shade val="100000"/>
+                <a:satMod val="130000"/>
+              </a:schemeClr>
+            </a:gs>
+            <a:gs pos="100000">
+              <a:schemeClr val="phClr">
+                <a:tint val="50000"/>
+                <a:shade val="100000"/>
+                <a:satMod val="350000"/>
+              </a:schemeClr>
+            </a:gs>
+          </a:gsLst>
+          <a:lin ang="16200000" scaled="0"/>
+        </a:gradFill>
+      </a:fillStyleLst>
+      <a:lnStyleLst>
+        <a:ln w="9525" cap="flat" cmpd="sng" algn="ctr">
+          <a:solidFill>
+            <a:schemeClr val="phClr">
+              <a:shade val="95000"/>
+              <a:satMod val="105000"/>
+            </a:schemeClr>
+          </a:solidFill>
+          <a:prstDash val="solid"/>
+        </a:ln>
+        <a:ln w="25400" cap="flat" cmpd="sng" algn="ctr">
+          <a:solidFill>
+            <a:schemeClr val="phClr"/>
+          </a:solidFill>
+          <a:prstDash val="solid"/>
+        </a:ln>
+        <a:ln w="38100" cap="flat" cmpd="sng" algn="ctr">
+          <a:solidFill>
+            <a:schemeClr val="phClr"/>
+          </a:solidFill>
+          <a:prstDash val="solid"/>
+        </a:ln>
+      </a:lnStyleLst>
+      <a:effectStyleLst>
+        <a:effectStyle>
+          <a:effectLst>
+            <a:outerShdw blurRad="40000" dist="20000" dir="5400000" rotWithShape="0">
+              <a:srgbClr val="000000">
+                <a:alpha val="38000"/>
+              </a:srgbClr>
+            </a:outerShdw>
+          </a:effectLst>
+        </a:effectStyle>
+        <a:effectStyle>
+          <a:effectLst>
+            <a:outerShdw blurRad="40000" dist="23000" dir="5400000" rotWithShape="0">
+              <a:srgbClr val="000000">
+                <a:alpha val="35000"/>
+              </a:srgbClr>
+            </a:outerShdw>
+          </a:effectLst>
+        </a:effectStyle>
+        <a:effectStyle>
+          <a:effectLst>
+            <a:outerShdw blurRad="40000" dist="23000" dir="5400000" rotWithShape="0">
+              <a:srgbClr val="000000">
+                <a:alpha val="35000"/>
+              </a:srgbClr>
+            </a:outerShdw>
+          </a:effectLst>
+          <a:scene3d>
+            <a:camera prst="orthographicFront">
+              <a:rot lat="0" lon="0" rev="0"/>
+            </a:camera>
+            <a:lightRig rig="threePt" dir="t">
+              <a:rot lat="0" lon="0" rev="1200000"/>
+            </a:lightRig>
+          </a:scene3d>
+          <a:sp3d>
+            <a:bevelT w="63500" h="25400"/>
+          </a:sp3d>
+        </a:effectStyle>
+      </a:effectStyleLst>
+      <a:bgFillStyleLst>
+        <a:solidFill>
+          <a:schemeClr val="phClr"/>
+        </a:solidFill>
+        <a:gradFill rotWithShape="1">
+          <a:gsLst>
+            <a:gs pos="0">
+              <a:schemeClr val="phClr">
+                <a:tint val="40000"/>
+                <a:satMod val="350000"/>
+              </a:schemeClr>
+            </a:gs>
+            <a:gs pos="40000">
+              <a:schemeClr val="phClr">
+                <a:tint val="45000"/>
+                <a:shade val="99000"/>
+                <a:satMod val="350000"/>
+              </a:schemeClr>
+            </a:gs>
+            <a:gs pos="100000">
+              <a:schemeClr val="phClr">
+                <a:shade val="20000"/>
+                <a:satMod val="255000"/>
+              </a:schemeClr>
+            </a:gs>
+          </a:gsLst>
+          <a:path path="circle">
+            <a:fillToRect l="50000" t="-80000" r="50000" b="180000"/>
+          </a:path>
+        </a:gradFill>
+        <a:gradFill rotWithShape="1">
+          <a:gsLst>
+            <a:gs pos="0">
+              <a:schemeClr val="phClr">
+                <a:tint val="80000"/>
+                <a:satMod val="300000"/>
+              </a:schemeClr>
+            </a:gs>
+            <a:gs pos="100000">
+              <a:schemeClr val="phClr">
+                <a:shade val="30000"/>
+                <a:satMod val="200000"/>
+              </a:schemeClr>
+            </a:gs>
+          </a:gsLst>
+          <a:path path="circle">
+            <a:fillToRect l="50000" t="50000" r="50000" b="50000"/>
+          </a:path>
+        </a:gradFill>
+      </a:bgFillStyleLst>
+    </a:fmtScheme>
+  </a:themeElements>
+  <a:objectDefaults>
+    <a:spDef>
+      <a:spPr/>
+      <a:bodyPr/>
+      <a:lstStyle/>
+      <a:style>
+        <a:lnRef idx="1">
+          <a:schemeClr val="accent1"/>
+        </a:lnRef>
+        <a:fillRef idx="3">
+          <a:schemeClr val="accent1"/>
+        </a:fillRef>
+        <a:effectRef idx="2">
+          <a:schemeClr val="accent1"/>
+        </a:effectRef>
+        <a:fontRef idx="minor">
+          <a:schemeClr val="lt1"/>
+        </a:fontRef>
+      </a:style>
+    </a:spDef>
+    <a:lnDef>
+      <a:spPr/>
+      <a:bodyPr/>
+      <a:lstStyle/>
+      <a:style>
+        <a:lnRef idx="2">
+          <a:schemeClr val="accent1"/>
+        </a:lnRef>
+        <a:fillRef idx="0">
+          <a:schemeClr val="accent1"/>
+        </a:fillRef>
+        <a:effectRef idx="1">
+          <a:schemeClr val="accent1"/>
+        </a:effectRef>
+        <a:fontRef idx="minor">
+          <a:schemeClr val="tx1"/>
+        </a:fontRef>
+      </a:style>
+    </a:lnDef>
+  </a:objectDefaults>
+  <a:extraClrSchemeLst/>
+</a:theme>
 </file>
</xml_diff>